<commit_message>
Fill in team details: student names, registration numbers, and project guide
</commit_message>
<xml_diff>
--- a/ppt/Review2_Panel_Presentation.pptx
+++ b/ppt/Review2_Panel_Presentation.pptx
@@ -2219,7 +2219,7 @@
         <p:spPr>
           <a:xfrm>
             <a:off x="9692640" y="1097280"/>
-            <a:ext cx="1645920" cy="2194560"/>
+            <a:ext cx="1188720" cy="822960"/>
           </a:xfrm>
           <a:prstGeom prst="line">
             <a:avLst/>
@@ -2240,9 +2240,9 @@
           <p:nvPr/>
         </p:nvSpPr>
         <p:spPr>
-          <a:xfrm flipH="1">
-            <a:off x="9326880" y="1920240"/>
-            <a:ext cx="1554480" cy="457200"/>
+          <a:xfrm>
+            <a:off x="9692640" y="1097280"/>
+            <a:ext cx="640080" cy="3291840"/>
           </a:xfrm>
           <a:prstGeom prst="line">
             <a:avLst/>
@@ -2264,8 +2264,8 @@
         </p:nvSpPr>
         <p:spPr>
           <a:xfrm flipH="1">
-            <a:off x="8778240" y="1920240"/>
-            <a:ext cx="2103120" cy="1828800"/>
+            <a:off x="9144000" y="1097280"/>
+            <a:ext cx="548640" cy="4206240"/>
           </a:xfrm>
           <a:prstGeom prst="line">
             <a:avLst/>
@@ -2287,8 +2287,8 @@
         </p:nvSpPr>
         <p:spPr>
           <a:xfrm>
-            <a:off x="10881360" y="1920240"/>
-            <a:ext cx="640080" cy="3200400"/>
+            <a:off x="9692640" y="1097280"/>
+            <a:ext cx="1828800" cy="4023360"/>
           </a:xfrm>
           <a:prstGeom prst="line">
             <a:avLst/>
@@ -2310,8 +2310,8 @@
         </p:nvSpPr>
         <p:spPr>
           <a:xfrm flipH="1">
-            <a:off x="8778240" y="2377440"/>
-            <a:ext cx="548640" cy="1371600"/>
+            <a:off x="9144000" y="1920240"/>
+            <a:ext cx="1737360" cy="3383280"/>
           </a:xfrm>
           <a:prstGeom prst="line">
             <a:avLst/>
@@ -2332,9 +2332,9 @@
           <p:nvPr/>
         </p:nvSpPr>
         <p:spPr>
-          <a:xfrm flipH="1">
-            <a:off x="9144000" y="2377440"/>
-            <a:ext cx="182880" cy="2926080"/>
+          <a:xfrm>
+            <a:off x="10881360" y="1920240"/>
+            <a:ext cx="640080" cy="3200400"/>
           </a:xfrm>
           <a:prstGeom prst="line">
             <a:avLst/>
@@ -2355,9 +2355,9 @@
           <p:nvPr/>
         </p:nvSpPr>
         <p:spPr>
-          <a:xfrm>
-            <a:off x="8778240" y="3749040"/>
-            <a:ext cx="1554480" cy="640080"/>
+          <a:xfrm flipH="1">
+            <a:off x="8778240" y="2377440"/>
+            <a:ext cx="548640" cy="1371600"/>
           </a:xfrm>
           <a:prstGeom prst="line">
             <a:avLst/>
@@ -2379,8 +2379,8 @@
         </p:nvSpPr>
         <p:spPr>
           <a:xfrm>
-            <a:off x="8778240" y="3749040"/>
-            <a:ext cx="365760" cy="1554480"/>
+            <a:off x="9326880" y="2377440"/>
+            <a:ext cx="1005840" cy="2011680"/>
           </a:xfrm>
           <a:prstGeom prst="line">
             <a:avLst/>
@@ -2401,9 +2401,9 @@
           <p:nvPr/>
         </p:nvSpPr>
         <p:spPr>
-          <a:xfrm>
-            <a:off x="10332720" y="4389120"/>
-            <a:ext cx="1188720" cy="731520"/>
+          <a:xfrm flipH="1">
+            <a:off x="8778240" y="3291840"/>
+            <a:ext cx="2560320" cy="457200"/>
           </a:xfrm>
           <a:prstGeom prst="line">
             <a:avLst/>
@@ -2424,6 +2424,98 @@
           <p:nvPr/>
         </p:nvSpPr>
         <p:spPr>
+          <a:xfrm flipH="1">
+            <a:off x="10332720" y="3291840"/>
+            <a:ext cx="1005840" cy="1097280"/>
+          </a:xfrm>
+          <a:prstGeom prst="line">
+            <a:avLst/>
+          </a:prstGeom>
+          <a:noFill/>
+          <a:ln w="12700">
+            <a:solidFill>
+              <a:srgbClr val="3A5A8C"/>
+            </a:solidFill>
+            <a:prstDash val="solid"/>
+          </a:ln>
+        </p:spPr>
+      </p:sp>
+      <p:sp>
+        <p:nvSpPr>
+          <p:cNvPr id="12" name="Shape 10"/>
+          <p:cNvSpPr/>
+          <p:nvPr/>
+        </p:nvSpPr>
+        <p:spPr>
+          <a:xfrm>
+            <a:off x="8778240" y="3749040"/>
+            <a:ext cx="365760" cy="1554480"/>
+          </a:xfrm>
+          <a:prstGeom prst="line">
+            <a:avLst/>
+          </a:prstGeom>
+          <a:noFill/>
+          <a:ln w="12700">
+            <a:solidFill>
+              <a:srgbClr val="3A5A8C"/>
+            </a:solidFill>
+            <a:prstDash val="solid"/>
+          </a:ln>
+        </p:spPr>
+      </p:sp>
+      <p:sp>
+        <p:nvSpPr>
+          <p:cNvPr id="13" name="Shape 11"/>
+          <p:cNvSpPr/>
+          <p:nvPr/>
+        </p:nvSpPr>
+        <p:spPr>
+          <a:xfrm>
+            <a:off x="8778240" y="3749040"/>
+            <a:ext cx="2743200" cy="1371600"/>
+          </a:xfrm>
+          <a:prstGeom prst="line">
+            <a:avLst/>
+          </a:prstGeom>
+          <a:noFill/>
+          <a:ln w="12700">
+            <a:solidFill>
+              <a:srgbClr val="3A5A8C"/>
+            </a:solidFill>
+            <a:prstDash val="solid"/>
+          </a:ln>
+        </p:spPr>
+      </p:sp>
+      <p:sp>
+        <p:nvSpPr>
+          <p:cNvPr id="14" name="Shape 12"/>
+          <p:cNvSpPr/>
+          <p:nvPr/>
+        </p:nvSpPr>
+        <p:spPr>
+          <a:xfrm flipH="1">
+            <a:off x="9144000" y="4389120"/>
+            <a:ext cx="1188720" cy="914400"/>
+          </a:xfrm>
+          <a:prstGeom prst="line">
+            <a:avLst/>
+          </a:prstGeom>
+          <a:noFill/>
+          <a:ln w="12700">
+            <a:solidFill>
+              <a:srgbClr val="3A5A8C"/>
+            </a:solidFill>
+            <a:prstDash val="solid"/>
+          </a:ln>
+        </p:spPr>
+      </p:sp>
+      <p:sp>
+        <p:nvSpPr>
+          <p:cNvPr id="15" name="Shape 13"/>
+          <p:cNvSpPr/>
+          <p:nvPr/>
+        </p:nvSpPr>
+        <p:spPr>
           <a:xfrm>
             <a:off x="9610344" y="1014984"/>
             <a:ext cx="164592" cy="164592"/>
@@ -2439,7 +2531,7 @@
       </p:sp>
       <p:sp>
         <p:nvSpPr>
-          <p:cNvPr id="12" name="Shape 10"/>
+          <p:cNvPr id="16" name="Shape 14"/>
           <p:cNvSpPr/>
           <p:nvPr/>
         </p:nvSpPr>
@@ -2459,7 +2551,7 @@
       </p:sp>
       <p:sp>
         <p:nvSpPr>
-          <p:cNvPr id="13" name="Shape 11"/>
+          <p:cNvPr id="17" name="Shape 15"/>
           <p:cNvSpPr/>
           <p:nvPr/>
         </p:nvSpPr>
@@ -2479,7 +2571,7 @@
       </p:sp>
       <p:sp>
         <p:nvSpPr>
-          <p:cNvPr id="14" name="Shape 12"/>
+          <p:cNvPr id="18" name="Shape 16"/>
           <p:cNvSpPr/>
           <p:nvPr/>
         </p:nvSpPr>
@@ -2499,7 +2591,7 @@
       </p:sp>
       <p:sp>
         <p:nvSpPr>
-          <p:cNvPr id="15" name="Shape 13"/>
+          <p:cNvPr id="19" name="Shape 17"/>
           <p:cNvSpPr/>
           <p:nvPr/>
         </p:nvSpPr>
@@ -2519,7 +2611,7 @@
       </p:sp>
       <p:sp>
         <p:nvSpPr>
-          <p:cNvPr id="16" name="Shape 14"/>
+          <p:cNvPr id="20" name="Shape 18"/>
           <p:cNvSpPr/>
           <p:nvPr/>
         </p:nvSpPr>
@@ -2539,7 +2631,7 @@
       </p:sp>
       <p:sp>
         <p:nvSpPr>
-          <p:cNvPr id="17" name="Shape 15"/>
+          <p:cNvPr id="21" name="Shape 19"/>
           <p:cNvSpPr/>
           <p:nvPr/>
         </p:nvSpPr>
@@ -2559,7 +2651,7 @@
       </p:sp>
       <p:sp>
         <p:nvSpPr>
-          <p:cNvPr id="18" name="Shape 16"/>
+          <p:cNvPr id="22" name="Shape 20"/>
           <p:cNvSpPr/>
           <p:nvPr/>
         </p:nvSpPr>
@@ -2579,7 +2671,7 @@
       </p:sp>
       <p:sp>
         <p:nvSpPr>
-          <p:cNvPr id="19" name="Text 17"/>
+          <p:cNvPr id="23" name="Text 21"/>
           <p:cNvSpPr/>
           <p:nvPr/>
         </p:nvSpPr>
@@ -2618,7 +2710,7 @@
       </p:sp>
       <p:sp>
         <p:nvSpPr>
-          <p:cNvPr id="20" name="Text 18"/>
+          <p:cNvPr id="24" name="Text 22"/>
           <p:cNvSpPr/>
           <p:nvPr/>
         </p:nvSpPr>
@@ -2700,7 +2792,7 @@
       </p:sp>
       <p:sp>
         <p:nvSpPr>
-          <p:cNvPr id="21" name="Text 19"/>
+          <p:cNvPr id="25" name="Text 23"/>
           <p:cNvSpPr/>
           <p:nvPr/>
         </p:nvSpPr>
@@ -2739,7 +2831,7 @@
       </p:sp>
       <p:sp>
         <p:nvSpPr>
-          <p:cNvPr id="22" name="Shape 20"/>
+          <p:cNvPr id="26" name="Shape 24"/>
           <p:cNvSpPr/>
           <p:nvPr/>
         </p:nvSpPr>
@@ -2759,14 +2851,14 @@
       </p:sp>
       <p:sp>
         <p:nvSpPr>
-          <p:cNvPr id="23" name="Text 21"/>
-          <p:cNvSpPr/>
-          <p:nvPr/>
-        </p:nvSpPr>
-        <p:spPr>
-          <a:xfrm>
-            <a:off x="640080" y="4709160"/>
-            <a:ext cx="8778240" cy="365760"/>
+          <p:cNvPr id="27" name="Text 25"/>
+          <p:cNvSpPr/>
+          <p:nvPr/>
+        </p:nvSpPr>
+        <p:spPr>
+          <a:xfrm>
+            <a:off x="640080" y="4663440"/>
+            <a:ext cx="8778240" cy="777240"/>
           </a:xfrm>
           <a:prstGeom prst="rect">
             <a:avLst/>
@@ -2779,6 +2871,9 @@
           <a:lstStyle/>
           <a:p>
             <a:pPr indent="0" marL="0">
+              <a:lnSpc>
+                <a:spcPct val="125000"/>
+              </a:lnSpc>
               <a:buNone/>
             </a:pPr>
             <a:r>
@@ -2792,7 +2887,13 @@
               </a:rPr>
               <a:t>Presented by: </a:t>
             </a:r>
+            <a:endParaRPr lang="en-US" sz="1400" dirty="0"/>
+          </a:p>
+          <a:p>
             <a:pPr indent="0" marL="0">
+              <a:lnSpc>
+                <a:spcPct val="125000"/>
+              </a:lnSpc>
               <a:buNone/>
             </a:pPr>
             <a:r>
@@ -2804,60 +2905,80 @@
                 <a:ea typeface="Calibri" pitchFamily="34" charset="-122"/>
                 <a:cs typeface="Calibri" pitchFamily="34" charset="-120"/>
               </a:rPr>
-              <a:t>[Student Name(s)] — [Registration Number(s)]</a:t>
+              <a:t>Aakash Sivakumar — 23BCE5119</a:t>
             </a:r>
             <a:endParaRPr lang="en-US" sz="1400" dirty="0"/>
           </a:p>
-        </p:txBody>
-      </p:sp>
-      <p:sp>
-        <p:nvSpPr>
-          <p:cNvPr id="24" name="Text 22"/>
-          <p:cNvSpPr/>
-          <p:nvPr/>
-        </p:nvSpPr>
-        <p:spPr>
-          <a:xfrm>
-            <a:off x="640080" y="5120640"/>
-            <a:ext cx="8778240" cy="365760"/>
-          </a:xfrm>
-          <a:prstGeom prst="rect">
-            <a:avLst/>
-          </a:prstGeom>
-          <a:noFill/>
-          <a:ln/>
-        </p:spPr>
-        <p:txBody>
-          <a:bodyPr wrap="square" rtlCol="0" anchor="ctr"/>
-          <a:lstStyle/>
           <a:p>
             <a:pPr indent="0" marL="0">
-              <a:buNone/>
-            </a:pPr>
-            <a:r>
-              <a:rPr lang="en-US" sz="1400" b="1" dirty="0">
-                <a:solidFill>
-                  <a:srgbClr val="8FD3E8"/>
+              <a:lnSpc>
+                <a:spcPct val="125000"/>
+              </a:lnSpc>
+              <a:buNone/>
+            </a:pPr>
+            <a:r>
+              <a:rPr lang="en-US" sz="1400" dirty="0">
+                <a:solidFill>
+                  <a:srgbClr val="FFFFFF"/>
                 </a:solidFill>
                 <a:latin typeface="Calibri" pitchFamily="34" charset="0"/>
                 <a:ea typeface="Calibri" pitchFamily="34" charset="-122"/>
                 <a:cs typeface="Calibri" pitchFamily="34" charset="-120"/>
               </a:rPr>
-              <a:t>Guide: </a:t>
-            </a:r>
+              <a:t>Udhay Anand Pandiyan — 23BCE1793</a:t>
+            </a:r>
+            <a:endParaRPr lang="en-US" sz="1400" dirty="0"/>
+          </a:p>
+        </p:txBody>
+      </p:sp>
+      <p:sp>
+        <p:nvSpPr>
+          <p:cNvPr id="28" name="Text 26"/>
+          <p:cNvSpPr/>
+          <p:nvPr/>
+        </p:nvSpPr>
+        <p:spPr>
+          <a:xfrm>
+            <a:off x="640080" y="5486400"/>
+            <a:ext cx="8778240" cy="365760"/>
+          </a:xfrm>
+          <a:prstGeom prst="rect">
+            <a:avLst/>
+          </a:prstGeom>
+          <a:noFill/>
+          <a:ln/>
+        </p:spPr>
+        <p:txBody>
+          <a:bodyPr wrap="square" rtlCol="0" anchor="ctr"/>
+          <a:lstStyle/>
+          <a:p>
             <a:pPr indent="0" marL="0">
               <a:buNone/>
             </a:pPr>
             <a:r>
-              <a:rPr lang="en-US" sz="1400" dirty="0">
-                <a:solidFill>
-                  <a:srgbClr val="FFFFFF"/>
+              <a:rPr lang="en-US" sz="1400" b="1" dirty="0">
+                <a:solidFill>
+                  <a:srgbClr val="8FD3E8"/>
                 </a:solidFill>
                 <a:latin typeface="Calibri" pitchFamily="34" charset="0"/>
                 <a:ea typeface="Calibri" pitchFamily="34" charset="-122"/>
                 <a:cs typeface="Calibri" pitchFamily="34" charset="-120"/>
               </a:rPr>
-              <a:t>[Project Guide Name]</a:t>
+              <a:t>Guide: </a:t>
+            </a:r>
+            <a:pPr indent="0" marL="0">
+              <a:buNone/>
+            </a:pPr>
+            <a:r>
+              <a:rPr lang="en-US" sz="1400" dirty="0">
+                <a:solidFill>
+                  <a:srgbClr val="FFFFFF"/>
+                </a:solidFill>
+                <a:latin typeface="Calibri" pitchFamily="34" charset="0"/>
+                <a:ea typeface="Calibri" pitchFamily="34" charset="-122"/>
+                <a:cs typeface="Calibri" pitchFamily="34" charset="-120"/>
+              </a:rPr>
+              <a:t>Jenila Livingston L M</a:t>
             </a:r>
             <a:endParaRPr lang="en-US" sz="1400" dirty="0"/>
           </a:p>
@@ -2865,13 +2986,13 @@
       </p:sp>
       <p:sp>
         <p:nvSpPr>
-          <p:cNvPr id="25" name="Text 23"/>
-          <p:cNvSpPr/>
-          <p:nvPr/>
-        </p:nvSpPr>
-        <p:spPr>
-          <a:xfrm>
-            <a:off x="640080" y="5532120"/>
+          <p:cNvPr id="29" name="Text 27"/>
+          <p:cNvSpPr/>
+          <p:nvPr/>
+        </p:nvSpPr>
+        <p:spPr>
+          <a:xfrm>
+            <a:off x="640080" y="5897880"/>
             <a:ext cx="8778240" cy="365760"/>
           </a:xfrm>
           <a:prstGeom prst="rect">

</xml_diff>